<commit_message>
Makale1: add article link button to the last slide
Co-Authored-By: Claude Sonnet 5.5 <noreply@anthropic.com>
Claude-Session: https://claude.ai/code/session_01TyFKmLJqyxNygHvjK9ydxU
</commit_message>
<xml_diff>
--- a/Makale1_Gorsel_Sunum.pptx
+++ b/Makale1_Gorsel_Sunum.pptx
@@ -11265,6 +11265,75 @@
               <a:t>24</a:t>
             </a:fld>
             <a:endParaRPr lang="tr-TR"/>
+          </a:p>
+        </p:txBody>
+      </p:sp>
+      <p:sp>
+        <p:nvSpPr>
+          <p:cNvPr id="7" name="Rounded Rectangle 6">
+            <a:hlinkClick r:id="rId2"/>
+          </p:cNvPr>
+          <p:cNvSpPr/>
+          <p:nvPr/>
+        </p:nvSpPr>
+        <p:spPr>
+          <a:xfrm>
+            <a:off x="457200" y="5257800"/>
+            <a:ext cx="7543800" cy="1005840"/>
+          </a:xfrm>
+          <a:prstGeom prst="roundRect">
+            <a:avLst>
+              <a:gd name="adj" fmla="val 20000"/>
+            </a:avLst>
+          </a:prstGeom>
+          <a:solidFill>
+            <a:srgbClr val="E36C0A"/>
+          </a:solidFill>
+          <a:ln>
+            <a:noFill/>
+          </a:ln>
+          <a:effectLst/>
+        </p:spPr>
+        <p:style>
+          <a:lnRef idx="1">
+            <a:schemeClr val="accent1"/>
+          </a:lnRef>
+          <a:fillRef idx="3">
+            <a:schemeClr val="accent1"/>
+          </a:fillRef>
+          <a:effectRef idx="2">
+            <a:schemeClr val="accent1"/>
+          </a:effectRef>
+          <a:fontRef idx="minor">
+            <a:schemeClr val="lt1"/>
+          </a:fontRef>
+        </p:style>
+        <p:txBody>
+          <a:bodyPr rtlCol="0" anchor="ctr" wrap="square"/>
+          <a:lstStyle/>
+          <a:p>
+            <a:pPr algn="ctr"/>
+            <a:r>
+              <a:rPr sz="2200" b="1">
+                <a:solidFill>
+                  <a:srgbClr val="FFFFFF"/>
+                </a:solidFill>
+                <a:latin typeface="Times New Roman"/>
+              </a:rPr>
+              <a:t>Makalenin tamamı bir tık uzağınızda</a:t>
+            </a:r>
+          </a:p>
+          <a:p>
+            <a:pPr algn="ctr"/>
+            <a:r>
+              <a:rPr sz="1800" b="0">
+                <a:solidFill>
+                  <a:srgbClr val="FFFFFF"/>
+                </a:solidFill>
+                <a:latin typeface="Times New Roman"/>
+              </a:rPr>
+              <a:t>Okumak için buraya tıklayın  ›</a:t>
+            </a:r>
           </a:p>
         </p:txBody>
       </p:sp>

</xml_diff>

<commit_message>
Makale1: make link button text and shape clickable
Co-Authored-By: Claude Sonnet 5.5 <noreply@anthropic.com>
Claude-Session: https://claude.ai/code/session_01TyFKmLJqyxNygHvjK9ydxU
</commit_message>
<xml_diff>
--- a/Makale1_Gorsel_Sunum.pptx
+++ b/Makale1_Gorsel_Sunum.pptx
@@ -11287,10 +11287,12 @@
             </a:avLst>
           </a:prstGeom>
           <a:solidFill>
-            <a:srgbClr val="E36C0A"/>
+            <a:srgbClr val="FFF1E0"/>
           </a:solidFill>
-          <a:ln>
-            <a:noFill/>
+          <a:ln w="38100">
+            <a:solidFill>
+              <a:srgbClr val="E36C0A"/>
+            </a:solidFill>
           </a:ln>
           <a:effectLst/>
         </p:spPr>
@@ -11319,6 +11321,7 @@
                   <a:srgbClr val="FFFFFF"/>
                 </a:solidFill>
                 <a:latin typeface="Times New Roman"/>
+                <a:hlinkClick r:id="rId2"/>
               </a:rPr>
               <a:t>Makalenin tamamı bir tık uzağınızda</a:t>
             </a:r>
@@ -11331,6 +11334,7 @@
                   <a:srgbClr val="FFFFFF"/>
                 </a:solidFill>
                 <a:latin typeface="Times New Roman"/>
+                <a:hlinkClick r:id="rId2"/>
               </a:rPr>
               <a:t>Okumak için buraya tıklayın  ›</a:t>
             </a:r>

</xml_diff>